<commit_message>
Update working repository at D:\paimana-ai
</commit_message>
<xml_diff>
--- a/sih_submission/SIH_2026_Final_Submission_Visual_Architecture.pptx
+++ b/sih_submission/SIH_2026_Final_Submission_Visual_Architecture.pptx
@@ -5,7 +5,7 @@
     <p:sldMasterId id="2147483648" r:id="rId1"/>
   </p:sldMasterIdLst>
   <p:notesMasterIdLst>
-    <p:notesMasterId r:id="rId9"/>
+    <p:notesMasterId r:id="rId8"/>
   </p:notesMasterIdLst>
   <p:sldIdLst>
     <p:sldId id="291" r:id="rId2"/>
@@ -14,7 +14,6 @@
     <p:sldId id="293" r:id="rId5"/>
     <p:sldId id="294" r:id="rId6"/>
     <p:sldId id="296" r:id="rId7"/>
-    <p:sldId id="297" r:id="rId8"/>
   </p:sldIdLst>
   <p:sldSz cx="12192000" cy="6858000"/>
   <p:notesSz cx="6858000" cy="9144000"/>
@@ -262,7 +261,7 @@
             <a:fld id="{C4D5ADD5-2BBC-4A94-8F86-D9013941F742}" type="datetimeFigureOut">
               <a:rPr lang="en-US"/>
               <a:pPr/>
-              <a:t>6/2/2026</a:t>
+              <a:t>10/1/2026</a:t>
             </a:fld>
             <a:endParaRPr lang="en-US"/>
           </a:p>
@@ -1352,184 +1351,6 @@
 </p:notes>
 </file>
 
-<file path=ppt/notesSlides/notesSlide6.xml><?xml version="1.0" encoding="utf-8"?>
-<p:notes xmlns:a="http://schemas.openxmlformats.org/drawingml/2006/main" xmlns:r="http://schemas.openxmlformats.org/officeDocument/2006/relationships" xmlns:p="http://schemas.openxmlformats.org/presentationml/2006/main">
-  <p:cSld>
-    <p:spTree>
-      <p:nvGrpSpPr>
-        <p:cNvPr id="1" name=""/>
-        <p:cNvGrpSpPr/>
-        <p:nvPr/>
-      </p:nvGrpSpPr>
-      <p:grpSpPr>
-        <a:xfrm>
-          <a:off x="0" y="0"/>
-          <a:ext cx="0" cy="0"/>
-          <a:chOff x="0" y="0"/>
-          <a:chExt cx="0" cy="0"/>
-        </a:xfrm>
-      </p:grpSpPr>
-      <p:sp>
-        <p:nvSpPr>
-          <p:cNvPr id="18433" name="Slide Image Placeholder 1"/>
-          <p:cNvSpPr>
-            <a:spLocks noGrp="1" noRot="1" noChangeAspect="1"/>
-          </p:cNvSpPr>
-          <p:nvPr>
-            <p:ph type="sldImg"/>
-          </p:nvPr>
-        </p:nvSpPr>
-        <p:spPr bwMode="auto">
-          <a:xfrm>
-            <a:off x="381000" y="685800"/>
-            <a:ext cx="6096000" cy="3429000"/>
-          </a:xfrm>
-          <a:noFill/>
-          <a:ln>
-            <a:solidFill>
-              <a:srgbClr val="000000"/>
-            </a:solidFill>
-            <a:miter lim="800000"/>
-            <a:headEnd/>
-            <a:tailEnd/>
-          </a:ln>
-        </p:spPr>
-      </p:sp>
-      <p:sp>
-        <p:nvSpPr>
-          <p:cNvPr id="18434" name="Notes Placeholder 2"/>
-          <p:cNvSpPr>
-            <a:spLocks noGrp="1"/>
-          </p:cNvSpPr>
-          <p:nvPr>
-            <p:ph type="body" idx="1"/>
-          </p:nvPr>
-        </p:nvSpPr>
-        <p:spPr bwMode="auto">
-          <a:noFill/>
-        </p:spPr>
-        <p:txBody>
-          <a:bodyPr wrap="square" numCol="1" anchor="t" anchorCtr="0" compatLnSpc="1">
-            <a:prstTxWarp prst="textNoShape">
-              <a:avLst/>
-            </a:prstTxWarp>
-          </a:bodyPr>
-          <a:lstStyle/>
-          <a:p>
-            <a:pPr eaLnBrk="1" hangingPunct="1">
-              <a:spcBef>
-                <a:spcPct val="0"/>
-              </a:spcBef>
-            </a:pPr>
-            <a:endParaRPr lang="en-US">
-              <a:ea typeface="ＭＳ Ｐゴシック" pitchFamily="1" charset="-128"/>
-            </a:endParaRPr>
-          </a:p>
-        </p:txBody>
-      </p:sp>
-      <p:sp>
-        <p:nvSpPr>
-          <p:cNvPr id="18435" name="Slide Number Placeholder 3"/>
-          <p:cNvSpPr>
-            <a:spLocks noGrp="1"/>
-          </p:cNvSpPr>
-          <p:nvPr>
-            <p:ph type="sldNum" sz="quarter" idx="5"/>
-          </p:nvPr>
-        </p:nvSpPr>
-        <p:spPr bwMode="auto">
-          <a:noFill/>
-          <a:ln>
-            <a:miter lim="800000"/>
-            <a:headEnd/>
-            <a:tailEnd/>
-          </a:ln>
-        </p:spPr>
-        <p:txBody>
-          <a:bodyPr/>
-          <a:lstStyle/>
-          <a:p>
-            <a:pPr marL="0" marR="0" lvl="0" indent="0" algn="r" defTabSz="457200" rtl="0" eaLnBrk="1" fontAlgn="base" latinLnBrk="0" hangingPunct="1">
-              <a:lnSpc>
-                <a:spcPct val="100000"/>
-              </a:lnSpc>
-              <a:spcBef>
-                <a:spcPct val="0"/>
-              </a:spcBef>
-              <a:spcAft>
-                <a:spcPct val="0"/>
-              </a:spcAft>
-              <a:buClrTx/>
-              <a:buSzTx/>
-              <a:buFontTx/>
-              <a:buNone/>
-              <a:tabLst/>
-              <a:defRPr/>
-            </a:pPr>
-            <a:fld id="{0CA7B74D-3791-4AC6-8451-F10DBCCCDD9A}" type="slidenum">
-              <a:rPr kumimoji="0" lang="en-US" sz="1200" b="0" i="0" u="none" strike="noStrike" kern="1200" cap="none" spc="0" normalizeH="0" baseline="0" noProof="0">
-                <a:ln>
-                  <a:noFill/>
-                </a:ln>
-                <a:solidFill>
-                  <a:prstClr val="black"/>
-                </a:solidFill>
-                <a:effectLst/>
-                <a:uLnTx/>
-                <a:uFillTx/>
-                <a:latin typeface="Calibri" pitchFamily="34" charset="0"/>
-                <a:ea typeface="ＭＳ Ｐゴシック" pitchFamily="1" charset="-128"/>
-                <a:cs typeface="+mn-cs"/>
-              </a:rPr>
-              <a:pPr marL="0" marR="0" lvl="0" indent="0" algn="r" defTabSz="457200" rtl="0" eaLnBrk="1" fontAlgn="base" latinLnBrk="0" hangingPunct="1">
-                <a:lnSpc>
-                  <a:spcPct val="100000"/>
-                </a:lnSpc>
-                <a:spcBef>
-                  <a:spcPct val="0"/>
-                </a:spcBef>
-                <a:spcAft>
-                  <a:spcPct val="0"/>
-                </a:spcAft>
-                <a:buClrTx/>
-                <a:buSzTx/>
-                <a:buFontTx/>
-                <a:buNone/>
-                <a:tabLst/>
-                <a:defRPr/>
-              </a:pPr>
-              <a:t>7</a:t>
-            </a:fld>
-            <a:endParaRPr kumimoji="0" lang="en-US" sz="1200" b="0" i="0" u="none" strike="noStrike" kern="1200" cap="none" spc="0" normalizeH="0" baseline="0" noProof="0">
-              <a:ln>
-                <a:noFill/>
-              </a:ln>
-              <a:solidFill>
-                <a:prstClr val="black"/>
-              </a:solidFill>
-              <a:effectLst/>
-              <a:uLnTx/>
-              <a:uFillTx/>
-              <a:latin typeface="Calibri" pitchFamily="34" charset="0"/>
-              <a:ea typeface="ＭＳ Ｐゴシック" pitchFamily="1" charset="-128"/>
-              <a:cs typeface="+mn-cs"/>
-            </a:endParaRPr>
-          </a:p>
-        </p:txBody>
-      </p:sp>
-    </p:spTree>
-    <p:extLst>
-      <p:ext uri="{BB962C8B-B14F-4D97-AF65-F5344CB8AC3E}">
-        <p14:creationId xmlns:p14="http://schemas.microsoft.com/office/powerpoint/2010/main" val="3783576877"/>
-      </p:ext>
-    </p:extLst>
-  </p:cSld>
-  <p:clrMapOvr>
-    <a:masterClrMapping/>
-  </p:clrMapOvr>
-</p:notes>
-</file>
-
 <file path=ppt/slideLayouts/slideLayout1.xml><?xml version="1.0" encoding="utf-8"?>
 <p:sldLayout xmlns:a="http://schemas.openxmlformats.org/drawingml/2006/main" xmlns:r="http://schemas.openxmlformats.org/officeDocument/2006/relationships" xmlns:p="http://schemas.openxmlformats.org/presentationml/2006/main" type="title" preserve="1">
   <p:cSld name="Title Slide">
@@ -1713,7 +1534,7 @@
           <a:p>
             <a:fld id="{E60792E3-D524-454C-8AFD-A91972900BCB}" type="datetime1">
               <a:rPr lang="en-US" smtClean="0"/>
-              <a:t>6/2/2026</a:t>
+              <a:t>10/1/2026</a:t>
             </a:fld>
             <a:endParaRPr lang="en-US"/>
           </a:p>
@@ -1895,7 +1716,7 @@
           <a:p>
             <a:fld id="{053C3A68-6922-42D3-8905-ECC2D82A3469}" type="datetime1">
               <a:rPr lang="en-US" smtClean="0"/>
-              <a:t>6/2/2026</a:t>
+              <a:t>10/1/2026</a:t>
             </a:fld>
             <a:endParaRPr lang="en-US"/>
           </a:p>
@@ -2087,7 +1908,7 @@
           <a:p>
             <a:fld id="{CB69E9F4-7604-4950-A8B2-8ACDEDB1506E}" type="datetime1">
               <a:rPr lang="en-US" smtClean="0"/>
-              <a:t>6/2/2026</a:t>
+              <a:t>10/1/2026</a:t>
             </a:fld>
             <a:endParaRPr lang="en-US"/>
           </a:p>
@@ -2269,7 +2090,7 @@
           <a:p>
             <a:fld id="{708B7524-32A2-4C20-A58C-BC3BAA1042FC}" type="datetime1">
               <a:rPr lang="en-US" smtClean="0"/>
-              <a:t>6/2/2026</a:t>
+              <a:t>10/1/2026</a:t>
             </a:fld>
             <a:endParaRPr lang="en-US"/>
           </a:p>
@@ -2528,7 +2349,7 @@
           <a:p>
             <a:fld id="{1E994447-D6B2-43BB-A877-57F1A267B999}" type="datetime1">
               <a:rPr lang="en-US" smtClean="0"/>
-              <a:t>6/2/2026</a:t>
+              <a:t>10/1/2026</a:t>
             </a:fld>
             <a:endParaRPr lang="en-US"/>
           </a:p>
@@ -2827,7 +2648,7 @@
           <a:p>
             <a:fld id="{68920E16-BD35-483C-AA6B-346FC7E46DEA}" type="datetime1">
               <a:rPr lang="en-US" smtClean="0"/>
-              <a:t>6/2/2026</a:t>
+              <a:t>10/1/2026</a:t>
             </a:fld>
             <a:endParaRPr lang="en-US"/>
           </a:p>
@@ -3260,7 +3081,7 @@
           <a:p>
             <a:fld id="{2FEAC6F8-5103-4FC0-A69E-5C6AE6469DA8}" type="datetime1">
               <a:rPr lang="en-US" smtClean="0"/>
-              <a:t>6/2/2026</a:t>
+              <a:t>10/1/2026</a:t>
             </a:fld>
             <a:endParaRPr lang="en-US"/>
           </a:p>
@@ -3391,7 +3212,7 @@
           <a:p>
             <a:fld id="{C60C6921-0627-4C8F-83D5-0CF936D2FFDD}" type="datetime1">
               <a:rPr lang="en-US" smtClean="0"/>
-              <a:t>6/2/2026</a:t>
+              <a:t>10/1/2026</a:t>
             </a:fld>
             <a:endParaRPr lang="en-US"/>
           </a:p>
@@ -3500,7 +3321,7 @@
           <a:p>
             <a:fld id="{2FF08AD7-8103-40F8-983C-E2BA6BB9CBE0}" type="datetime1">
               <a:rPr lang="en-US" smtClean="0"/>
-              <a:t>6/2/2026</a:t>
+              <a:t>10/1/2026</a:t>
             </a:fld>
             <a:endParaRPr lang="en-US"/>
           </a:p>
@@ -3789,7 +3610,7 @@
           <a:p>
             <a:fld id="{DF8C06B4-9380-4A4D-AF49-A3596E17DAF5}" type="datetime1">
               <a:rPr lang="en-US" smtClean="0"/>
-              <a:t>6/2/2026</a:t>
+              <a:t>10/1/2026</a:t>
             </a:fld>
             <a:endParaRPr lang="en-US"/>
           </a:p>
@@ -4058,7 +3879,7 @@
           <a:p>
             <a:fld id="{EF7FDEF1-C582-4E22-9E77-D68326471F28}" type="datetime1">
               <a:rPr lang="en-US" smtClean="0"/>
-              <a:t>6/2/2026</a:t>
+              <a:t>10/1/2026</a:t>
             </a:fld>
             <a:endParaRPr lang="en-US"/>
           </a:p>
@@ -4301,7 +4122,7 @@
           <a:p>
             <a:fld id="{780A9602-A9A9-453F-AEF1-37B5837E02CD}" type="datetime1">
               <a:rPr lang="en-US" smtClean="0"/>
-              <a:t>6/2/2026</a:t>
+              <a:t>10/1/2026</a:t>
             </a:fld>
             <a:endParaRPr lang="en-US"/>
           </a:p>
@@ -4852,7 +4673,7 @@
                 <a16:creationId xmlns:a16="http://schemas.microsoft.com/office/drawing/2014/main" id="{3E443FD7-A66B-4AA0-872D-B088B9BC5F17}"/>
               </a:ext>
               <a:ext uri="{C183D7F6-B498-43B3-948B-1728B52AA6E4}">
-                <adec:decorative xmlns:adec="http://schemas.microsoft.com/office/drawing/2017/decorative" xmlns="" val="1"/>
+                <adec:decorative xmlns:adec="http://schemas.microsoft.com/office/drawing/2017/decorative" val="1"/>
               </a:ext>
             </a:extLst>
           </p:cNvPr>
@@ -4912,7 +4733,7 @@
                 <a16:creationId xmlns:a16="http://schemas.microsoft.com/office/drawing/2014/main" id="{C04BE0EF-3561-49B4-9A29-F283168A91C7}"/>
               </a:ext>
               <a:ext uri="{C183D7F6-B498-43B3-948B-1728B52AA6E4}">
-                <adec:decorative xmlns:adec="http://schemas.microsoft.com/office/drawing/2017/decorative" xmlns="" val="1"/>
+                <adec:decorative xmlns:adec="http://schemas.microsoft.com/office/drawing/2017/decorative" val="1"/>
               </a:ext>
             </a:extLst>
           </p:cNvPr>
@@ -5783,16 +5604,7 @@
                 </a:solidFill>
                 <a:latin typeface="Garamond" panose="02020404030301010803" pitchFamily="18" charset="0"/>
               </a:rPr>
-              <a:t>SMART INDIA HACKATHON </a:t>
-            </a:r>
-            <a:r>
-              <a:rPr lang="en-US" sz="4000" b="1" dirty="0" smtClean="0">
-                <a:solidFill>
-                  <a:schemeClr val="tx2"/>
-                </a:solidFill>
-                <a:latin typeface="Garamond" panose="02020404030301010803" pitchFamily="18" charset="0"/>
-              </a:rPr>
-              <a:t>2026</a:t>
+              <a:t>SMART INDIA HACKATHON 2026</a:t>
             </a:r>
             <a:endParaRPr lang="en-IN" sz="4000" b="1" dirty="0">
               <a:solidFill>
@@ -5811,8 +5623,8 @@
         </p:nvSpPr>
         <p:spPr>
           <a:xfrm>
-            <a:off x="331286" y="2076450"/>
-            <a:ext cx="5924550" cy="4703019"/>
+            <a:off x="331286" y="2076449"/>
+            <a:ext cx="6150990" cy="4657685"/>
           </a:xfrm>
           <a:prstGeom prst="rect">
             <a:avLst/>
@@ -5834,7 +5646,7 @@
               </a:spcAft>
             </a:pPr>
             <a:r>
-              <a:rPr b="1" sz="1150">
+              <a:rPr b="1" dirty="0">
                 <a:solidFill>
                   <a:srgbClr val="E06D14"/>
                 </a:solidFill>
@@ -5843,7 +5655,7 @@
               <a:t>Problem Statement ID: </a:t>
             </a:r>
             <a:r>
-              <a:rPr sz="1150">
+              <a:rPr dirty="0">
                 <a:solidFill>
                   <a:srgbClr val="1E293B"/>
                 </a:solidFill>
@@ -5859,7 +5671,7 @@
               </a:spcAft>
             </a:pPr>
             <a:r>
-              <a:rPr b="1" sz="1150">
+              <a:rPr b="1" dirty="0">
                 <a:solidFill>
                   <a:srgbClr val="E06D14"/>
                 </a:solidFill>
@@ -5868,7 +5680,7 @@
               <a:t>Problem Statement Title: </a:t>
             </a:r>
             <a:r>
-              <a:rPr sz="1150">
+              <a:rPr dirty="0">
                 <a:solidFill>
                   <a:srgbClr val="1E293B"/>
                 </a:solidFill>
@@ -5884,7 +5696,7 @@
               </a:spcAft>
             </a:pPr>
             <a:r>
-              <a:rPr b="1" sz="1150">
+              <a:rPr b="1" dirty="0">
                 <a:solidFill>
                   <a:srgbClr val="E06D14"/>
                 </a:solidFill>
@@ -5893,7 +5705,7 @@
               <a:t>Theme: </a:t>
             </a:r>
             <a:r>
-              <a:rPr sz="1150">
+              <a:rPr dirty="0">
                 <a:solidFill>
                   <a:srgbClr val="1E293B"/>
                 </a:solidFill>
@@ -5909,7 +5721,7 @@
               </a:spcAft>
             </a:pPr>
             <a:r>
-              <a:rPr b="1" sz="1150">
+              <a:rPr b="1" dirty="0">
                 <a:solidFill>
                   <a:srgbClr val="E06D14"/>
                 </a:solidFill>
@@ -5918,7 +5730,7 @@
               <a:t>PS Category: </a:t>
             </a:r>
             <a:r>
-              <a:rPr sz="1150">
+              <a:rPr dirty="0">
                 <a:solidFill>
                   <a:srgbClr val="1E293B"/>
                 </a:solidFill>
@@ -5934,7 +5746,7 @@
               </a:spcAft>
             </a:pPr>
             <a:r>
-              <a:rPr b="1" sz="1150">
+              <a:rPr b="1" dirty="0">
                 <a:solidFill>
                   <a:srgbClr val="E06D14"/>
                 </a:solidFill>
@@ -5943,13 +5755,49 @@
               <a:t>Ministry: </a:t>
             </a:r>
             <a:r>
-              <a:rPr sz="1150">
+              <a:rPr dirty="0">
                 <a:solidFill>
                   <a:srgbClr val="1E293B"/>
                 </a:solidFill>
                 <a:latin typeface="Calibri"/>
               </a:rPr>
-              <a:t>Ministry of Statistics and Programme Implementation (MoSPI)</a:t>
+              <a:t>Ministry of Statistics and </a:t>
+            </a:r>
+            <a:r>
+              <a:rPr dirty="0" err="1">
+                <a:solidFill>
+                  <a:srgbClr val="1E293B"/>
+                </a:solidFill>
+                <a:latin typeface="Calibri"/>
+              </a:rPr>
+              <a:t>Programme</a:t>
+            </a:r>
+            <a:r>
+              <a:rPr dirty="0">
+                <a:solidFill>
+                  <a:srgbClr val="1E293B"/>
+                </a:solidFill>
+                <a:latin typeface="Calibri"/>
+              </a:rPr>
+              <a:t> Implementation (</a:t>
+            </a:r>
+            <a:r>
+              <a:rPr dirty="0" err="1">
+                <a:solidFill>
+                  <a:srgbClr val="1E293B"/>
+                </a:solidFill>
+                <a:latin typeface="Calibri"/>
+              </a:rPr>
+              <a:t>MoSPI</a:t>
+            </a:r>
+            <a:r>
+              <a:rPr dirty="0">
+                <a:solidFill>
+                  <a:srgbClr val="1E293B"/>
+                </a:solidFill>
+                <a:latin typeface="Calibri"/>
+              </a:rPr>
+              <a:t>)</a:t>
             </a:r>
           </a:p>
           <a:p>
@@ -5959,7 +5807,7 @@
               </a:spcAft>
             </a:pPr>
             <a:r>
-              <a:rPr b="1" sz="1150">
+              <a:rPr b="1" dirty="0">
                 <a:solidFill>
                   <a:srgbClr val="E06D14"/>
                 </a:solidFill>
@@ -5968,7 +5816,7 @@
               <a:t>Department: </a:t>
             </a:r>
             <a:r>
-              <a:rPr sz="1150">
+              <a:rPr dirty="0">
                 <a:solidFill>
                   <a:srgbClr val="1E293B"/>
                 </a:solidFill>
@@ -5984,23 +5832,47 @@
               </a:spcAft>
             </a:pPr>
             <a:r>
-              <a:rPr b="1" sz="1150">
+              <a:rPr b="1" dirty="0">
                 <a:solidFill>
                   <a:srgbClr val="E06D14"/>
                 </a:solidFill>
                 <a:latin typeface="Arial"/>
               </a:rPr>
-              <a:t>Team Name: </a:t>
-            </a:r>
-            <a:r>
-              <a:rPr sz="1150">
+              <a:t>Team </a:t>
+            </a:r>
+            <a:r>
+              <a:rPr lang="en-US" b="1" dirty="0">
+                <a:solidFill>
+                  <a:srgbClr val="E06D14"/>
+                </a:solidFill>
+                <a:latin typeface="Arial"/>
+              </a:rPr>
+              <a:t>ID</a:t>
+            </a:r>
+            <a:r>
+              <a:rPr b="1" dirty="0">
+                <a:solidFill>
+                  <a:srgbClr val="E06D14"/>
+                </a:solidFill>
+                <a:latin typeface="Arial"/>
+              </a:rPr>
+              <a:t>: </a:t>
+            </a:r>
+            <a:r>
+              <a:rPr lang="en-US" b="1" dirty="0">
                 <a:solidFill>
                   <a:srgbClr val="1E293B"/>
                 </a:solidFill>
                 <a:latin typeface="Calibri"/>
               </a:rPr>
-              <a:t>Team InfraVision</a:t>
-            </a:r>
+              <a:t>SIH-059</a:t>
+            </a:r>
+            <a:endParaRPr dirty="0">
+              <a:solidFill>
+                <a:srgbClr val="1E293B"/>
+              </a:solidFill>
+              <a:latin typeface="Calibri"/>
+            </a:endParaRPr>
           </a:p>
           <a:p>
             <a:pPr>
@@ -6009,7 +5881,7 @@
               </a:spcAft>
             </a:pPr>
             <a:r>
-              <a:rPr b="1" sz="1150">
+              <a:rPr b="1" dirty="0">
                 <a:solidFill>
                   <a:srgbClr val="E06D14"/>
                 </a:solidFill>
@@ -6018,7 +5890,7 @@
               <a:t>GitHub Repository: </a:t>
             </a:r>
             <a:r>
-              <a:rPr sz="1150">
+              <a:rPr dirty="0">
                 <a:solidFill>
                   <a:srgbClr val="1E293B"/>
                 </a:solidFill>
@@ -6034,7 +5906,7 @@
               </a:spcAft>
             </a:pPr>
             <a:r>
-              <a:rPr b="1" sz="1150">
+              <a:rPr b="1" dirty="0">
                 <a:solidFill>
                   <a:srgbClr val="E06D14"/>
                 </a:solidFill>
@@ -6043,7 +5915,7 @@
               <a:t>Live Working Prototype: </a:t>
             </a:r>
             <a:r>
-              <a:rPr sz="1150">
+              <a:rPr dirty="0">
                 <a:solidFill>
                   <a:srgbClr val="1E293B"/>
                 </a:solidFill>
@@ -6122,7 +5994,7 @@
           </a:fontRef>
         </p:style>
         <p:txBody>
-          <a:bodyPr rtlCol="0" anchor="ctr" wrap="square"/>
+          <a:bodyPr wrap="square" rtlCol="0" anchor="ctr"/>
           <a:lstStyle/>
           <a:p>
             <a:pPr algn="ctr">
@@ -6391,7 +6263,7 @@
                 <a16:creationId xmlns:a16="http://schemas.microsoft.com/office/drawing/2014/main" id="{5DBCE864-823D-4A13-9607-5DA1F0ED5FB8}"/>
               </a:ext>
               <a:ext uri="{C183D7F6-B498-43B3-948B-1728B52AA6E4}">
-                <adec:decorative xmlns:adec="http://schemas.microsoft.com/office/drawing/2017/decorative" xmlns="" val="0"/>
+                <adec:decorative xmlns:adec="http://schemas.microsoft.com/office/drawing/2017/decorative" val="0"/>
               </a:ext>
             </a:extLst>
           </p:cNvPr>
@@ -6400,8 +6272,8 @@
         </p:nvSpPr>
         <p:spPr>
           <a:xfrm>
-            <a:off x="329773" y="252246"/>
-            <a:ext cx="1251857" cy="807334"/>
+            <a:off x="357808" y="84393"/>
+            <a:ext cx="1356787" cy="807334"/>
           </a:xfrm>
           <a:prstGeom prst="ellipse">
             <a:avLst/>
@@ -6426,8 +6298,20 @@
           <a:lstStyle/>
           <a:p>
             <a:r>
-              <a:t>Team InfraVision</a:t>
-            </a:r>
+              <a:rPr lang="en-US" b="1" dirty="0" err="1">
+                <a:solidFill>
+                  <a:schemeClr val="tx1"/>
+                </a:solidFill>
+                <a:latin typeface="New times"/>
+              </a:rPr>
+              <a:t>VigilEye</a:t>
+            </a:r>
+            <a:endParaRPr b="1" dirty="0">
+              <a:solidFill>
+                <a:schemeClr val="tx1"/>
+              </a:solidFill>
+              <a:latin typeface="New times"/>
+            </a:endParaRPr>
           </a:p>
         </p:txBody>
       </p:sp>
@@ -6503,6 +6387,7 @@
           <a:lstStyle/>
           <a:p>
             <a:pPr algn="ctr"/>
+            <a:endParaRPr/>
           </a:p>
         </p:txBody>
       </p:sp>
@@ -6674,6 +6559,7 @@
           <a:lstStyle/>
           <a:p>
             <a:pPr algn="ctr"/>
+            <a:endParaRPr/>
           </a:p>
         </p:txBody>
       </p:sp>
@@ -6719,6 +6605,7 @@
           <a:lstStyle/>
           <a:p>
             <a:pPr algn="ctr"/>
+            <a:endParaRPr/>
           </a:p>
         </p:txBody>
       </p:sp>
@@ -6890,6 +6777,7 @@
           <a:lstStyle/>
           <a:p>
             <a:pPr algn="ctr"/>
+            <a:endParaRPr/>
           </a:p>
         </p:txBody>
       </p:sp>
@@ -6935,6 +6823,7 @@
           <a:lstStyle/>
           <a:p>
             <a:pPr algn="ctr"/>
+            <a:endParaRPr/>
           </a:p>
         </p:txBody>
       </p:sp>
@@ -7106,6 +6995,7 @@
           <a:lstStyle/>
           <a:p>
             <a:pPr algn="ctr"/>
+            <a:endParaRPr/>
           </a:p>
         </p:txBody>
       </p:sp>
@@ -7151,6 +7041,7 @@
           <a:lstStyle/>
           <a:p>
             <a:pPr algn="ctr"/>
+            <a:endParaRPr/>
           </a:p>
         </p:txBody>
       </p:sp>
@@ -7322,6 +7213,7 @@
           <a:lstStyle/>
           <a:p>
             <a:pPr algn="ctr"/>
+            <a:endParaRPr/>
           </a:p>
         </p:txBody>
       </p:sp>
@@ -7367,6 +7259,7 @@
           <a:lstStyle/>
           <a:p>
             <a:pPr algn="ctr"/>
+            <a:endParaRPr/>
           </a:p>
         </p:txBody>
       </p:sp>
@@ -7506,7 +7399,7 @@
         </p:nvSpPr>
         <p:spPr>
           <a:xfrm>
-            <a:off x="548640" y="3657600"/>
+            <a:off x="467360" y="3664748"/>
             <a:ext cx="3566160" cy="2606040"/>
           </a:xfrm>
           <a:prstGeom prst="roundRect">
@@ -7536,7 +7429,7 @@
           </a:fontRef>
         </p:style>
         <p:txBody>
-          <a:bodyPr rtlCol="0" anchor="ctr" wrap="square"/>
+          <a:bodyPr wrap="square" rtlCol="0" anchor="ctr"/>
           <a:lstStyle/>
           <a:p>
             <a:pPr algn="ctr">
@@ -7548,6 +7441,7 @@
               </a:defRPr>
             </a:pPr>
             <a:r>
+              <a:rPr sz="1400" dirty="0"/>
               <a:t>Detailed Explanation of Proposed Solution</a:t>
             </a:r>
           </a:p>
@@ -7564,7 +7458,16 @@
               </a:defRPr>
             </a:pPr>
             <a:r>
-              <a:t>• Transforms MoSPI infrastructure monitoring from descriptive reports into an autonomous predictive &amp; prescriptive system.</a:t>
+              <a:rPr sz="1200" dirty="0"/>
+              <a:t>• Transforms </a:t>
+            </a:r>
+            <a:r>
+              <a:rPr sz="1200" dirty="0" err="1"/>
+              <a:t>MoSPI</a:t>
+            </a:r>
+            <a:r>
+              <a:rPr sz="1200" dirty="0"/>
+              <a:t> infrastructure monitoring from descriptive reports into an autonomous predictive &amp; prescriptive system.</a:t>
             </a:r>
           </a:p>
           <a:p>
@@ -7580,6 +7483,7 @@
               </a:defRPr>
             </a:pPr>
             <a:r>
+              <a:rPr sz="1200" dirty="0"/>
               <a:t>• Deploys dual machine learning regressors to forecast cost escalations and schedule delays 6-12 months in advance.</a:t>
             </a:r>
           </a:p>
@@ -7596,6 +7500,7 @@
               </a:defRPr>
             </a:pPr>
             <a:r>
+              <a:rPr sz="1200" dirty="0"/>
               <a:t>• Calculates a Composite Risk Index (CRI 0-100) assigning dynamic Red/Amber/Green status across all 1,981 central projects.</a:t>
             </a:r>
           </a:p>
@@ -7639,7 +7544,7 @@
           </a:fontRef>
         </p:style>
         <p:txBody>
-          <a:bodyPr rtlCol="0" anchor="ctr" wrap="square"/>
+          <a:bodyPr wrap="square" rtlCol="0" anchor="ctr"/>
           <a:lstStyle/>
           <a:p>
             <a:pPr algn="ctr">
@@ -7651,6 +7556,7 @@
               </a:defRPr>
             </a:pPr>
             <a:r>
+              <a:rPr sz="1400" dirty="0"/>
               <a:t>How It Addresses The Problem</a:t>
             </a:r>
           </a:p>
@@ -7667,6 +7573,7 @@
               </a:defRPr>
             </a:pPr>
             <a:r>
+              <a:rPr sz="1400" dirty="0"/>
               <a:t>• Detects 'Ghost Progress' when financial spending outpaces verified physical progress by &gt;1.65x.</a:t>
             </a:r>
           </a:p>
@@ -7683,6 +7590,7 @@
               </a:defRPr>
             </a:pPr>
             <a:r>
+              <a:rPr sz="1400" dirty="0"/>
               <a:t>• Preempts Stage-II Forest Clearance and Land Acquisition bottlenecks before critical path milestones stall.</a:t>
             </a:r>
           </a:p>
@@ -7699,7 +7607,20 @@
               </a:defRPr>
             </a:pPr>
             <a:r>
-              <a:t>• Simulates What-If interventions (e.g. +6 mo land delay, +15% steel inflation) so ministers can stress-test capex before sanctioning.</a:t>
+              <a:rPr sz="1400" dirty="0"/>
+              <a:t>• Simulates What-If interventions (e.g. +6 </a:t>
+            </a:r>
+            <a:r>
+              <a:rPr sz="1400" dirty="0" err="1"/>
+              <a:t>mo</a:t>
+            </a:r>
+            <a:r>
+              <a:rPr sz="1400" dirty="0"/>
+              <a:t> land delay, +15% steel inflation) so ministers can stress-test capex before sanctioning</a:t>
+            </a:r>
+            <a:r>
+              <a:rPr dirty="0"/>
+              <a:t>.</a:t>
             </a:r>
           </a:p>
         </p:txBody>
@@ -7742,7 +7663,7 @@
           </a:fontRef>
         </p:style>
         <p:txBody>
-          <a:bodyPr rtlCol="0" anchor="ctr" wrap="square"/>
+          <a:bodyPr wrap="square" rtlCol="0" anchor="ctr"/>
           <a:lstStyle/>
           <a:p>
             <a:pPr algn="ctr">
@@ -7754,6 +7675,7 @@
               </a:defRPr>
             </a:pPr>
             <a:r>
+              <a:rPr sz="1400" dirty="0"/>
               <a:t>Innovation &amp; Uniqueness</a:t>
             </a:r>
           </a:p>
@@ -7770,6 +7692,7 @@
               </a:defRPr>
             </a:pPr>
             <a:r>
+              <a:rPr sz="1400" dirty="0"/>
               <a:t>• Proves AI superiority: Achieves +22.4% higher variance explained (R²) and +0.12 ROC-AUC over classical linear regressions.</a:t>
             </a:r>
           </a:p>
@@ -7786,6 +7709,7 @@
               </a:defRPr>
             </a:pPr>
             <a:r>
+              <a:rPr sz="1400" dirty="0"/>
               <a:t>• Evidence-based CUF reform: Demonstrates +16.8% variance uplift by adding 4 high-ROI fields to PAIMANA-CRIP.</a:t>
             </a:r>
           </a:p>
@@ -7802,6 +7726,7 @@
               </a:defRPr>
             </a:pPr>
             <a:r>
+              <a:rPr sz="1400" dirty="0"/>
               <a:t>• LLM Copilot: Instant ministerial executive briefings with targeted administrative escalation pathways.</a:t>
             </a:r>
           </a:p>
@@ -7957,6 +7882,7 @@
               <a:buFont typeface="Arial" panose="020B0604020202020204" pitchFamily="34" charset="0"/>
               <a:buChar char="•"/>
             </a:pPr>
+            <a:endParaRPr/>
           </a:p>
         </p:txBody>
       </p:sp>
@@ -8028,54 +7954,6 @@
                 <a:schemeClr val="bg1"/>
               </a:solidFill>
             </a:endParaRPr>
-          </a:p>
-        </p:txBody>
-      </p:sp>
-      <p:sp>
-        <p:nvSpPr>
-          <p:cNvPr id="11" name="Oval 10" descr="Your startup LOGO">
-            <a:extLst>
-              <a:ext uri="{FF2B5EF4-FFF2-40B4-BE49-F238E27FC236}">
-                <a16:creationId xmlns:a16="http://schemas.microsoft.com/office/drawing/2014/main" id="{5DBCE864-823D-4A13-9607-5DA1F0ED5FB8}"/>
-              </a:ext>
-              <a:ext uri="{C183D7F6-B498-43B3-948B-1728B52AA6E4}">
-                <adec:decorative xmlns:adec="http://schemas.microsoft.com/office/drawing/2017/decorative" xmlns="" val="0"/>
-              </a:ext>
-            </a:extLst>
-          </p:cNvPr>
-          <p:cNvSpPr/>
-          <p:nvPr/>
-        </p:nvSpPr>
-        <p:spPr>
-          <a:xfrm>
-            <a:off x="329773" y="252246"/>
-            <a:ext cx="1251857" cy="807334"/>
-          </a:xfrm>
-          <a:prstGeom prst="ellipse">
-            <a:avLst/>
-          </a:prstGeom>
-        </p:spPr>
-        <p:style>
-          <a:lnRef idx="2">
-            <a:schemeClr val="accent4"/>
-          </a:lnRef>
-          <a:fillRef idx="1">
-            <a:schemeClr val="lt1"/>
-          </a:fillRef>
-          <a:effectRef idx="0">
-            <a:schemeClr val="accent4"/>
-          </a:effectRef>
-          <a:fontRef idx="minor">
-            <a:schemeClr val="dk1"/>
-          </a:fontRef>
-        </p:style>
-        <p:txBody>
-          <a:bodyPr rtlCol="0" anchor="ctr"/>
-          <a:lstStyle/>
-          <a:p>
-            <a:r>
-              <a:t>Team InfraVision</a:t>
-            </a:r>
           </a:p>
         </p:txBody>
       </p:sp>
@@ -8125,8 +8003,8 @@
         </p:blipFill>
         <p:spPr>
           <a:xfrm>
-            <a:off x="548640" y="1143000"/>
-            <a:ext cx="7040880" cy="5074920"/>
+            <a:off x="579120" y="1164970"/>
+            <a:ext cx="7010399" cy="5052950"/>
           </a:xfrm>
           <a:prstGeom prst="rect">
             <a:avLst/>
@@ -8171,7 +8049,7 @@
           </a:fontRef>
         </p:style>
         <p:txBody>
-          <a:bodyPr rtlCol="0" anchor="ctr" wrap="square"/>
+          <a:bodyPr wrap="square" rtlCol="0" anchor="ctr"/>
           <a:lstStyle/>
           <a:p>
             <a:pPr algn="ctr">
@@ -8350,7 +8228,7 @@
         </p:blipFill>
         <p:spPr>
           <a:xfrm>
-            <a:off x="7818120" y="3236975"/>
+            <a:off x="7852200" y="3106043"/>
             <a:ext cx="1371600" cy="428625"/>
           </a:xfrm>
           <a:prstGeom prst="rect">
@@ -8603,6 +8481,66 @@
             <a:r>
               <a:t>100% Open Source | Zero Licensing Fees | Runs on 2 vCPUs</a:t>
             </a:r>
+          </a:p>
+        </p:txBody>
+      </p:sp>
+      <p:sp>
+        <p:nvSpPr>
+          <p:cNvPr id="3" name="Oval 2" descr="Your startup LOGO">
+            <a:extLst>
+              <a:ext uri="{FF2B5EF4-FFF2-40B4-BE49-F238E27FC236}">
+                <a16:creationId xmlns:a16="http://schemas.microsoft.com/office/drawing/2014/main" id="{C7AF8FEA-3651-70F0-6730-88FD29A33244}"/>
+              </a:ext>
+              <a:ext uri="{C183D7F6-B498-43B3-948B-1728B52AA6E4}">
+                <adec:decorative xmlns:adec="http://schemas.microsoft.com/office/drawing/2017/decorative" val="0"/>
+              </a:ext>
+            </a:extLst>
+          </p:cNvPr>
+          <p:cNvSpPr/>
+          <p:nvPr/>
+        </p:nvSpPr>
+        <p:spPr>
+          <a:xfrm>
+            <a:off x="273824" y="188089"/>
+            <a:ext cx="1356787" cy="807334"/>
+          </a:xfrm>
+          <a:prstGeom prst="ellipse">
+            <a:avLst/>
+          </a:prstGeom>
+        </p:spPr>
+        <p:style>
+          <a:lnRef idx="2">
+            <a:schemeClr val="accent4"/>
+          </a:lnRef>
+          <a:fillRef idx="1">
+            <a:schemeClr val="lt1"/>
+          </a:fillRef>
+          <a:effectRef idx="0">
+            <a:schemeClr val="accent4"/>
+          </a:effectRef>
+          <a:fontRef idx="minor">
+            <a:schemeClr val="dk1"/>
+          </a:fontRef>
+        </p:style>
+        <p:txBody>
+          <a:bodyPr rtlCol="0" anchor="ctr"/>
+          <a:lstStyle/>
+          <a:p>
+            <a:r>
+              <a:rPr lang="en-US" b="1" dirty="0" err="1">
+                <a:solidFill>
+                  <a:schemeClr val="tx1"/>
+                </a:solidFill>
+                <a:latin typeface="New times"/>
+              </a:rPr>
+              <a:t>VigilEye</a:t>
+            </a:r>
+            <a:endParaRPr b="1" dirty="0">
+              <a:solidFill>
+                <a:schemeClr val="tx1"/>
+              </a:solidFill>
+              <a:latin typeface="New times"/>
+            </a:endParaRPr>
           </a:p>
         </p:txBody>
       </p:sp>
@@ -8955,54 +8893,6 @@
           </a:p>
         </p:txBody>
       </p:sp>
-      <p:sp>
-        <p:nvSpPr>
-          <p:cNvPr id="12" name="Oval 11" descr="Your startup LOGO">
-            <a:extLst>
-              <a:ext uri="{FF2B5EF4-FFF2-40B4-BE49-F238E27FC236}">
-                <a16:creationId xmlns:a16="http://schemas.microsoft.com/office/drawing/2014/main" id="{5DBCE864-823D-4A13-9607-5DA1F0ED5FB8}"/>
-              </a:ext>
-              <a:ext uri="{C183D7F6-B498-43B3-948B-1728B52AA6E4}">
-                <adec:decorative xmlns:adec="http://schemas.microsoft.com/office/drawing/2017/decorative" xmlns="" val="0"/>
-              </a:ext>
-            </a:extLst>
-          </p:cNvPr>
-          <p:cNvSpPr/>
-          <p:nvPr/>
-        </p:nvSpPr>
-        <p:spPr>
-          <a:xfrm>
-            <a:off x="329773" y="252246"/>
-            <a:ext cx="1251857" cy="807334"/>
-          </a:xfrm>
-          <a:prstGeom prst="ellipse">
-            <a:avLst/>
-          </a:prstGeom>
-        </p:spPr>
-        <p:style>
-          <a:lnRef idx="2">
-            <a:schemeClr val="accent4"/>
-          </a:lnRef>
-          <a:fillRef idx="1">
-            <a:schemeClr val="lt1"/>
-          </a:fillRef>
-          <a:effectRef idx="0">
-            <a:schemeClr val="accent4"/>
-          </a:effectRef>
-          <a:fontRef idx="minor">
-            <a:schemeClr val="dk1"/>
-          </a:fontRef>
-        </p:style>
-        <p:txBody>
-          <a:bodyPr rtlCol="0" anchor="ctr"/>
-          <a:lstStyle/>
-          <a:p>
-            <a:r>
-              <a:t>Team InfraVision</a:t>
-            </a:r>
-          </a:p>
-        </p:txBody>
-      </p:sp>
       <p:pic>
         <p:nvPicPr>
           <p:cNvPr id="11" name="Picture 10"/>
@@ -9071,7 +8961,7 @@
           </a:fontRef>
         </p:style>
         <p:txBody>
-          <a:bodyPr rtlCol="0" anchor="ctr" wrap="square"/>
+          <a:bodyPr wrap="square" rtlCol="0" anchor="ctr"/>
           <a:lstStyle/>
           <a:p>
             <a:pPr algn="ctr">
@@ -9353,7 +9243,7 @@
           </a:fontRef>
         </p:style>
         <p:txBody>
-          <a:bodyPr rtlCol="0" anchor="ctr" wrap="square"/>
+          <a:bodyPr wrap="square" rtlCol="0" anchor="ctr"/>
           <a:lstStyle/>
           <a:p>
             <a:pPr algn="ctr">
@@ -9532,6 +9422,66 @@
             <a:r>
               <a:t>• Mitigation 3 (Scenario Simulator): Interactive What-If simulator allows administrators to stress-test ±30% inflation shocks in real time.</a:t>
             </a:r>
+          </a:p>
+        </p:txBody>
+      </p:sp>
+      <p:sp>
+        <p:nvSpPr>
+          <p:cNvPr id="5" name="Oval 4" descr="Your startup LOGO">
+            <a:extLst>
+              <a:ext uri="{FF2B5EF4-FFF2-40B4-BE49-F238E27FC236}">
+                <a16:creationId xmlns:a16="http://schemas.microsoft.com/office/drawing/2014/main" id="{6F2B9903-1385-C952-C1E4-AA1DD953F0BC}"/>
+              </a:ext>
+              <a:ext uri="{C183D7F6-B498-43B3-948B-1728B52AA6E4}">
+                <adec:decorative xmlns:adec="http://schemas.microsoft.com/office/drawing/2017/decorative" val="0"/>
+              </a:ext>
+            </a:extLst>
+          </p:cNvPr>
+          <p:cNvSpPr/>
+          <p:nvPr/>
+        </p:nvSpPr>
+        <p:spPr>
+          <a:xfrm>
+            <a:off x="273824" y="188089"/>
+            <a:ext cx="1356787" cy="807334"/>
+          </a:xfrm>
+          <a:prstGeom prst="ellipse">
+            <a:avLst/>
+          </a:prstGeom>
+        </p:spPr>
+        <p:style>
+          <a:lnRef idx="2">
+            <a:schemeClr val="accent4"/>
+          </a:lnRef>
+          <a:fillRef idx="1">
+            <a:schemeClr val="lt1"/>
+          </a:fillRef>
+          <a:effectRef idx="0">
+            <a:schemeClr val="accent4"/>
+          </a:effectRef>
+          <a:fontRef idx="minor">
+            <a:schemeClr val="dk1"/>
+          </a:fontRef>
+        </p:style>
+        <p:txBody>
+          <a:bodyPr rtlCol="0" anchor="ctr"/>
+          <a:lstStyle/>
+          <a:p>
+            <a:r>
+              <a:rPr lang="en-US" b="1" dirty="0" err="1">
+                <a:solidFill>
+                  <a:schemeClr val="tx1"/>
+                </a:solidFill>
+                <a:latin typeface="New times"/>
+              </a:rPr>
+              <a:t>VigilEye</a:t>
+            </a:r>
+            <a:endParaRPr b="1" dirty="0">
+              <a:solidFill>
+                <a:schemeClr val="tx1"/>
+              </a:solidFill>
+              <a:latin typeface="New times"/>
+            </a:endParaRPr>
           </a:p>
         </p:txBody>
       </p:sp>
@@ -9718,6 +9668,7 @@
               <a:tabLst/>
               <a:defRPr/>
             </a:pPr>
+            <a:endParaRPr/>
           </a:p>
         </p:txBody>
       </p:sp>
@@ -9875,54 +9826,6 @@
           </a:p>
         </p:txBody>
       </p:sp>
-      <p:sp>
-        <p:nvSpPr>
-          <p:cNvPr id="12" name="Oval 11" descr="Your startup LOGO">
-            <a:extLst>
-              <a:ext uri="{FF2B5EF4-FFF2-40B4-BE49-F238E27FC236}">
-                <a16:creationId xmlns:a16="http://schemas.microsoft.com/office/drawing/2014/main" id="{5DBCE864-823D-4A13-9607-5DA1F0ED5FB8}"/>
-              </a:ext>
-              <a:ext uri="{C183D7F6-B498-43B3-948B-1728B52AA6E4}">
-                <adec:decorative xmlns:adec="http://schemas.microsoft.com/office/drawing/2017/decorative" xmlns="" val="0"/>
-              </a:ext>
-            </a:extLst>
-          </p:cNvPr>
-          <p:cNvSpPr/>
-          <p:nvPr/>
-        </p:nvSpPr>
-        <p:spPr>
-          <a:xfrm>
-            <a:off x="329773" y="252246"/>
-            <a:ext cx="1251857" cy="807334"/>
-          </a:xfrm>
-          <a:prstGeom prst="ellipse">
-            <a:avLst/>
-          </a:prstGeom>
-        </p:spPr>
-        <p:style>
-          <a:lnRef idx="2">
-            <a:schemeClr val="accent4"/>
-          </a:lnRef>
-          <a:fillRef idx="1">
-            <a:schemeClr val="lt1"/>
-          </a:fillRef>
-          <a:effectRef idx="0">
-            <a:schemeClr val="accent4"/>
-          </a:effectRef>
-          <a:fontRef idx="minor">
-            <a:schemeClr val="dk1"/>
-          </a:fontRef>
-        </p:style>
-        <p:txBody>
-          <a:bodyPr rtlCol="0" anchor="ctr"/>
-          <a:lstStyle/>
-          <a:p>
-            <a:r>
-              <a:t>Team InfraVision</a:t>
-            </a:r>
-          </a:p>
-        </p:txBody>
-      </p:sp>
       <p:pic>
         <p:nvPicPr>
           <p:cNvPr id="11" name="Picture 10"/>
@@ -9991,7 +9894,7 @@
           </a:fontRef>
         </p:style>
         <p:txBody>
-          <a:bodyPr rtlCol="0" anchor="ctr" wrap="square"/>
+          <a:bodyPr wrap="square" rtlCol="0" anchor="ctr"/>
           <a:lstStyle/>
           <a:p>
             <a:pPr algn="ctr">
@@ -10094,7 +9997,7 @@
           </a:fontRef>
         </p:style>
         <p:txBody>
-          <a:bodyPr rtlCol="0" anchor="ctr" wrap="square"/>
+          <a:bodyPr wrap="square" rtlCol="0" anchor="ctr"/>
           <a:lstStyle/>
           <a:p>
             <a:pPr algn="ctr">
@@ -10197,7 +10100,7 @@
           </a:fontRef>
         </p:style>
         <p:txBody>
-          <a:bodyPr rtlCol="0" anchor="ctr" wrap="square"/>
+          <a:bodyPr wrap="square" rtlCol="0" anchor="ctr"/>
           <a:lstStyle/>
           <a:p>
             <a:pPr algn="ctr">
@@ -10300,7 +10203,7 @@
           </a:fontRef>
         </p:style>
         <p:txBody>
-          <a:bodyPr rtlCol="0" anchor="ctr" wrap="square"/>
+          <a:bodyPr wrap="square" rtlCol="0" anchor="ctr"/>
           <a:lstStyle/>
           <a:p>
             <a:pPr algn="ctr">
@@ -10362,6 +10265,66 @@
             <a:r>
               <a:t>3. State Chief Secretaries: Receive automated Stage-II Forest &amp; RFCTLARR Land Acquisition escalation dossiers for prompt district-level clearances.</a:t>
             </a:r>
+          </a:p>
+        </p:txBody>
+      </p:sp>
+      <p:sp>
+        <p:nvSpPr>
+          <p:cNvPr id="3" name="Oval 2" descr="Your startup LOGO">
+            <a:extLst>
+              <a:ext uri="{FF2B5EF4-FFF2-40B4-BE49-F238E27FC236}">
+                <a16:creationId xmlns:a16="http://schemas.microsoft.com/office/drawing/2014/main" id="{624D4D59-CAB8-2E2D-C201-37612B329D95}"/>
+              </a:ext>
+              <a:ext uri="{C183D7F6-B498-43B3-948B-1728B52AA6E4}">
+                <adec:decorative xmlns:adec="http://schemas.microsoft.com/office/drawing/2017/decorative" val="0"/>
+              </a:ext>
+            </a:extLst>
+          </p:cNvPr>
+          <p:cNvSpPr/>
+          <p:nvPr/>
+        </p:nvSpPr>
+        <p:spPr>
+          <a:xfrm>
+            <a:off x="273824" y="188089"/>
+            <a:ext cx="1356787" cy="807334"/>
+          </a:xfrm>
+          <a:prstGeom prst="ellipse">
+            <a:avLst/>
+          </a:prstGeom>
+        </p:spPr>
+        <p:style>
+          <a:lnRef idx="2">
+            <a:schemeClr val="accent4"/>
+          </a:lnRef>
+          <a:fillRef idx="1">
+            <a:schemeClr val="lt1"/>
+          </a:fillRef>
+          <a:effectRef idx="0">
+            <a:schemeClr val="accent4"/>
+          </a:effectRef>
+          <a:fontRef idx="minor">
+            <a:schemeClr val="dk1"/>
+          </a:fontRef>
+        </p:style>
+        <p:txBody>
+          <a:bodyPr rtlCol="0" anchor="ctr"/>
+          <a:lstStyle/>
+          <a:p>
+            <a:r>
+              <a:rPr lang="en-US" b="1" dirty="0" err="1">
+                <a:solidFill>
+                  <a:schemeClr val="tx1"/>
+                </a:solidFill>
+                <a:latin typeface="New times"/>
+              </a:rPr>
+              <a:t>VigilEye</a:t>
+            </a:r>
+            <a:endParaRPr b="1" dirty="0">
+              <a:solidFill>
+                <a:schemeClr val="tx1"/>
+              </a:solidFill>
+              <a:latin typeface="New times"/>
+            </a:endParaRPr>
           </a:p>
         </p:txBody>
       </p:sp>
@@ -10719,54 +10682,6 @@
           </a:p>
         </p:txBody>
       </p:sp>
-      <p:sp>
-        <p:nvSpPr>
-          <p:cNvPr id="9" name="Oval 8" descr="Your startup LOGO">
-            <a:extLst>
-              <a:ext uri="{FF2B5EF4-FFF2-40B4-BE49-F238E27FC236}">
-                <a16:creationId xmlns:a16="http://schemas.microsoft.com/office/drawing/2014/main" id="{5DBCE864-823D-4A13-9607-5DA1F0ED5FB8}"/>
-              </a:ext>
-              <a:ext uri="{C183D7F6-B498-43B3-948B-1728B52AA6E4}">
-                <adec:decorative xmlns:adec="http://schemas.microsoft.com/office/drawing/2017/decorative" xmlns="" val="0"/>
-              </a:ext>
-            </a:extLst>
-          </p:cNvPr>
-          <p:cNvSpPr/>
-          <p:nvPr/>
-        </p:nvSpPr>
-        <p:spPr>
-          <a:xfrm>
-            <a:off x="329773" y="252246"/>
-            <a:ext cx="1251857" cy="807334"/>
-          </a:xfrm>
-          <a:prstGeom prst="ellipse">
-            <a:avLst/>
-          </a:prstGeom>
-        </p:spPr>
-        <p:style>
-          <a:lnRef idx="2">
-            <a:schemeClr val="accent4"/>
-          </a:lnRef>
-          <a:fillRef idx="1">
-            <a:schemeClr val="lt1"/>
-          </a:fillRef>
-          <a:effectRef idx="0">
-            <a:schemeClr val="accent4"/>
-          </a:effectRef>
-          <a:fontRef idx="minor">
-            <a:schemeClr val="dk1"/>
-          </a:fontRef>
-        </p:style>
-        <p:txBody>
-          <a:bodyPr rtlCol="0" anchor="ctr"/>
-          <a:lstStyle/>
-          <a:p>
-            <a:r>
-              <a:t>Team InfraVision</a:t>
-            </a:r>
-          </a:p>
-        </p:txBody>
-      </p:sp>
       <p:pic>
         <p:nvPicPr>
           <p:cNvPr id="12" name="Picture 11"/>
@@ -10835,7 +10750,7 @@
           </a:fontRef>
         </p:style>
         <p:txBody>
-          <a:bodyPr rtlCol="0" anchor="ctr" wrap="square"/>
+          <a:bodyPr wrap="square" rtlCol="0" anchor="ctr"/>
           <a:lstStyle/>
           <a:p>
             <a:pPr algn="ctr">
@@ -11100,7 +11015,7 @@
           </a:fontRef>
         </p:style>
         <p:txBody>
-          <a:bodyPr rtlCol="0" anchor="ctr" wrap="square"/>
+          <a:bodyPr wrap="square" rtlCol="0" anchor="ctr"/>
           <a:lstStyle/>
           <a:p>
             <a:pPr algn="ctr">
@@ -11262,863 +11177,70 @@
           </a:p>
         </p:txBody>
       </p:sp>
+      <p:sp>
+        <p:nvSpPr>
+          <p:cNvPr id="5" name="Oval 4" descr="Your startup LOGO">
+            <a:extLst>
+              <a:ext uri="{FF2B5EF4-FFF2-40B4-BE49-F238E27FC236}">
+                <a16:creationId xmlns:a16="http://schemas.microsoft.com/office/drawing/2014/main" id="{4F7E8E85-F48B-27BD-09A8-5944CF9129BC}"/>
+              </a:ext>
+              <a:ext uri="{C183D7F6-B498-43B3-948B-1728B52AA6E4}">
+                <adec:decorative xmlns:adec="http://schemas.microsoft.com/office/drawing/2017/decorative" val="0"/>
+              </a:ext>
+            </a:extLst>
+          </p:cNvPr>
+          <p:cNvSpPr/>
+          <p:nvPr/>
+        </p:nvSpPr>
+        <p:spPr>
+          <a:xfrm>
+            <a:off x="273824" y="188089"/>
+            <a:ext cx="1356787" cy="807334"/>
+          </a:xfrm>
+          <a:prstGeom prst="ellipse">
+            <a:avLst/>
+          </a:prstGeom>
+        </p:spPr>
+        <p:style>
+          <a:lnRef idx="2">
+            <a:schemeClr val="accent4"/>
+          </a:lnRef>
+          <a:fillRef idx="1">
+            <a:schemeClr val="lt1"/>
+          </a:fillRef>
+          <a:effectRef idx="0">
+            <a:schemeClr val="accent4"/>
+          </a:effectRef>
+          <a:fontRef idx="minor">
+            <a:schemeClr val="dk1"/>
+          </a:fontRef>
+        </p:style>
+        <p:txBody>
+          <a:bodyPr rtlCol="0" anchor="ctr"/>
+          <a:lstStyle/>
+          <a:p>
+            <a:r>
+              <a:rPr lang="en-US" b="1" dirty="0" err="1">
+                <a:solidFill>
+                  <a:schemeClr val="tx1"/>
+                </a:solidFill>
+                <a:latin typeface="New times"/>
+              </a:rPr>
+              <a:t>VigilEye</a:t>
+            </a:r>
+            <a:endParaRPr b="1" dirty="0">
+              <a:solidFill>
+                <a:schemeClr val="tx1"/>
+              </a:solidFill>
+              <a:latin typeface="New times"/>
+            </a:endParaRPr>
+          </a:p>
+        </p:txBody>
+      </p:sp>
     </p:spTree>
     <p:extLst>
       <p:ext uri="{BB962C8B-B14F-4D97-AF65-F5344CB8AC3E}">
         <p14:creationId xmlns:p14="http://schemas.microsoft.com/office/powerpoint/2010/main" val="3916788613"/>
-      </p:ext>
-    </p:extLst>
-  </p:cSld>
-  <p:clrMapOvr>
-    <a:masterClrMapping/>
-  </p:clrMapOvr>
-</p:sld>
-</file>
-
-<file path=ppt/slides/slide7.xml><?xml version="1.0" encoding="utf-8"?>
-<p:sld xmlns:a="http://schemas.openxmlformats.org/drawingml/2006/main" xmlns:r="http://schemas.openxmlformats.org/officeDocument/2006/relationships" xmlns:p="http://schemas.openxmlformats.org/presentationml/2006/main">
-  <p:cSld>
-    <p:spTree>
-      <p:nvGrpSpPr>
-        <p:cNvPr id="1" name=""/>
-        <p:cNvGrpSpPr/>
-        <p:nvPr/>
-      </p:nvGrpSpPr>
-      <p:grpSpPr>
-        <a:xfrm>
-          <a:off x="0" y="0"/>
-          <a:ext cx="0" cy="0"/>
-          <a:chOff x="0" y="0"/>
-          <a:chExt cx="0" cy="0"/>
-        </a:xfrm>
-      </p:grpSpPr>
-      <p:sp>
-        <p:nvSpPr>
-          <p:cNvPr id="10" name="Rectangle 9">
-            <a:extLst>
-              <a:ext uri="{FF2B5EF4-FFF2-40B4-BE49-F238E27FC236}">
-                <a16:creationId xmlns:a16="http://schemas.microsoft.com/office/drawing/2014/main" id="{AD4F69D3-EEB0-4C4C-9434-B9960FB5854C}"/>
-              </a:ext>
-            </a:extLst>
-          </p:cNvPr>
-          <p:cNvSpPr>
-            <a:spLocks noChangeArrowheads="1"/>
-          </p:cNvSpPr>
-          <p:nvPr/>
-        </p:nvSpPr>
-        <p:spPr bwMode="auto">
-          <a:xfrm>
-            <a:off x="0" y="6354762"/>
-            <a:ext cx="12191999" cy="503238"/>
-          </a:xfrm>
-          <a:prstGeom prst="rect">
-            <a:avLst/>
-          </a:prstGeom>
-          <a:solidFill>
-            <a:srgbClr val="0070C0"/>
-          </a:solidFill>
-          <a:ln w="9525">
-            <a:noFill/>
-            <a:miter lim="800000"/>
-            <a:headEnd/>
-            <a:tailEnd/>
-          </a:ln>
-          <a:effectLst>
-            <a:outerShdw dist="23000" dir="5400000" rotWithShape="0">
-              <a:srgbClr val="808080">
-                <a:alpha val="34999"/>
-              </a:srgbClr>
-            </a:outerShdw>
-          </a:effectLst>
-        </p:spPr>
-        <p:txBody>
-          <a:bodyPr anchor="ctr"/>
-          <a:lstStyle/>
-          <a:p>
-            <a:pPr marL="0" marR="0" lvl="0" indent="0" algn="ctr" defTabSz="457200" rtl="0" eaLnBrk="1" fontAlgn="auto" latinLnBrk="0" hangingPunct="1">
-              <a:lnSpc>
-                <a:spcPct val="100000"/>
-              </a:lnSpc>
-              <a:spcBef>
-                <a:spcPts val="0"/>
-              </a:spcBef>
-              <a:spcAft>
-                <a:spcPts val="0"/>
-              </a:spcAft>
-              <a:buClrTx/>
-              <a:buSzTx/>
-              <a:buFontTx/>
-              <a:buNone/>
-              <a:tabLst/>
-              <a:defRPr/>
-            </a:pPr>
-            <a:endParaRPr kumimoji="0" lang="en-US" sz="1800" b="0" i="0" u="none" strike="noStrike" kern="1200" cap="none" spc="0" normalizeH="0" baseline="0" noProof="0" dirty="0">
-              <a:ln>
-                <a:noFill/>
-              </a:ln>
-              <a:solidFill>
-                <a:srgbClr val="C0504D">
-                  <a:lumMod val="75000"/>
-                </a:srgbClr>
-              </a:solidFill>
-              <a:effectLst/>
-              <a:uLnTx/>
-              <a:uFillTx/>
-              <a:latin typeface="Calibri"/>
-              <a:ea typeface="ＭＳ Ｐゴシック" pitchFamily="1" charset="-128"/>
-              <a:cs typeface="+mn-cs"/>
-            </a:endParaRPr>
-          </a:p>
-        </p:txBody>
-      </p:sp>
-      <p:sp>
-        <p:nvSpPr>
-          <p:cNvPr id="6" name="Slide Number Placeholder 5"/>
-          <p:cNvSpPr>
-            <a:spLocks noGrp="1"/>
-          </p:cNvSpPr>
-          <p:nvPr>
-            <p:ph type="sldNum" sz="quarter" idx="12"/>
-          </p:nvPr>
-        </p:nvSpPr>
-        <p:spPr/>
-        <p:txBody>
-          <a:bodyPr/>
-          <a:lstStyle/>
-          <a:p>
-            <a:pPr marL="0" marR="0" lvl="0" indent="0" algn="r" defTabSz="457200" rtl="0" eaLnBrk="1" fontAlgn="base" latinLnBrk="0" hangingPunct="1">
-              <a:lnSpc>
-                <a:spcPct val="100000"/>
-              </a:lnSpc>
-              <a:spcBef>
-                <a:spcPct val="0"/>
-              </a:spcBef>
-              <a:spcAft>
-                <a:spcPct val="0"/>
-              </a:spcAft>
-              <a:buClrTx/>
-              <a:buSzTx/>
-              <a:buFontTx/>
-              <a:buNone/>
-              <a:tabLst/>
-              <a:defRPr/>
-            </a:pPr>
-            <a:fld id="{677C3CE7-23F7-4828-823C-E0205DF2CF97}" type="slidenum">
-              <a:rPr kumimoji="0" lang="en-US" sz="1200" b="1" i="0" u="none" strike="noStrike" kern="1200" cap="none" spc="0" normalizeH="0" baseline="0" noProof="0">
-                <a:ln>
-                  <a:noFill/>
-                </a:ln>
-                <a:solidFill>
-                  <a:prstClr val="white"/>
-                </a:solidFill>
-                <a:effectLst/>
-                <a:uLnTx/>
-                <a:uFillTx/>
-                <a:latin typeface="TradeGothic" pitchFamily="1" charset="0"/>
-                <a:ea typeface="ＭＳ Ｐゴシック" pitchFamily="1" charset="-128"/>
-                <a:cs typeface="+mn-cs"/>
-              </a:rPr>
-              <a:pPr marL="0" marR="0" lvl="0" indent="0" algn="r" defTabSz="457200" rtl="0" eaLnBrk="1" fontAlgn="base" latinLnBrk="0" hangingPunct="1">
-                <a:lnSpc>
-                  <a:spcPct val="100000"/>
-                </a:lnSpc>
-                <a:spcBef>
-                  <a:spcPct val="0"/>
-                </a:spcBef>
-                <a:spcAft>
-                  <a:spcPct val="0"/>
-                </a:spcAft>
-                <a:buClrTx/>
-                <a:buSzTx/>
-                <a:buFontTx/>
-                <a:buNone/>
-                <a:tabLst/>
-                <a:defRPr/>
-              </a:pPr>
-              <a:t>7</a:t>
-            </a:fld>
-            <a:endParaRPr kumimoji="0" lang="en-US" sz="1200" b="1" i="0" u="none" strike="noStrike" kern="1200" cap="none" spc="0" normalizeH="0" baseline="0" noProof="0" dirty="0">
-              <a:ln>
-                <a:noFill/>
-              </a:ln>
-              <a:solidFill>
-                <a:prstClr val="white"/>
-              </a:solidFill>
-              <a:effectLst/>
-              <a:uLnTx/>
-              <a:uFillTx/>
-              <a:latin typeface="TradeGothic" pitchFamily="1" charset="0"/>
-              <a:ea typeface="ＭＳ Ｐゴシック" pitchFamily="1" charset="-128"/>
-              <a:cs typeface="+mn-cs"/>
-            </a:endParaRPr>
-          </a:p>
-        </p:txBody>
-      </p:sp>
-      <p:sp>
-        <p:nvSpPr>
-          <p:cNvPr id="7" name="Footer Placeholder 6"/>
-          <p:cNvSpPr>
-            <a:spLocks noGrp="1"/>
-          </p:cNvSpPr>
-          <p:nvPr>
-            <p:ph type="ftr" sz="quarter" idx="11"/>
-          </p:nvPr>
-        </p:nvSpPr>
-        <p:spPr>
-          <a:xfrm>
-            <a:off x="4648200" y="6356353"/>
-            <a:ext cx="3204000" cy="365125"/>
-          </a:xfrm>
-        </p:spPr>
-        <p:txBody>
-          <a:bodyPr/>
-          <a:lstStyle/>
-          <a:p>
-            <a:pPr marL="0" marR="0" lvl="0" indent="0" algn="ctr" defTabSz="457200" rtl="0" eaLnBrk="1" fontAlgn="auto" latinLnBrk="0" hangingPunct="1">
-              <a:lnSpc>
-                <a:spcPct val="100000"/>
-              </a:lnSpc>
-              <a:spcBef>
-                <a:spcPts val="0"/>
-              </a:spcBef>
-              <a:spcAft>
-                <a:spcPts val="0"/>
-              </a:spcAft>
-              <a:buClrTx/>
-              <a:buSzTx/>
-              <a:buFontTx/>
-              <a:buNone/>
-              <a:tabLst/>
-              <a:defRPr/>
-            </a:pPr>
-            <a:r>
-              <a:rPr kumimoji="0" lang="en-US" sz="1200" b="0" i="0" u="none" strike="noStrike" kern="1200" cap="none" spc="0" normalizeH="0" baseline="0" noProof="0">
-                <a:ln>
-                  <a:noFill/>
-                </a:ln>
-                <a:solidFill>
-                  <a:prstClr val="white"/>
-                </a:solidFill>
-                <a:effectLst/>
-                <a:uLnTx/>
-                <a:uFillTx/>
-                <a:latin typeface="TradeGothic"/>
-                <a:ea typeface="+mn-ea"/>
-                <a:cs typeface="+mn-cs"/>
-              </a:rPr>
-              <a:t>@SIH Idea submission- Template</a:t>
-            </a:r>
-            <a:endParaRPr kumimoji="0" lang="en-US" sz="1200" b="0" i="0" u="none" strike="noStrike" kern="1200" cap="none" spc="0" normalizeH="0" baseline="0" noProof="0" dirty="0">
-              <a:ln>
-                <a:noFill/>
-              </a:ln>
-              <a:solidFill>
-                <a:prstClr val="white"/>
-              </a:solidFill>
-              <a:effectLst/>
-              <a:uLnTx/>
-              <a:uFillTx/>
-              <a:latin typeface="TradeGothic"/>
-              <a:ea typeface="+mn-ea"/>
-              <a:cs typeface="+mn-cs"/>
-            </a:endParaRPr>
-          </a:p>
-        </p:txBody>
-      </p:sp>
-      <p:sp>
-        <p:nvSpPr>
-          <p:cNvPr id="3" name="Round Diagonal Corner Rectangle 2"/>
-          <p:cNvSpPr/>
-          <p:nvPr/>
-        </p:nvSpPr>
-        <p:spPr>
-          <a:xfrm>
-            <a:off x="0" y="1791032"/>
-            <a:ext cx="12192000" cy="4319200"/>
-          </a:xfrm>
-          <a:prstGeom prst="round2DiagRect">
-            <a:avLst/>
-          </a:prstGeom>
-          <a:solidFill>
-            <a:schemeClr val="accent1">
-              <a:lumMod val="20000"/>
-              <a:lumOff val="80000"/>
-            </a:schemeClr>
-          </a:solidFill>
-          <a:ln w="38100"/>
-        </p:spPr>
-        <p:style>
-          <a:lnRef idx="1">
-            <a:schemeClr val="accent1"/>
-          </a:lnRef>
-          <a:fillRef idx="3">
-            <a:schemeClr val="accent1"/>
-          </a:fillRef>
-          <a:effectRef idx="2">
-            <a:schemeClr val="accent1"/>
-          </a:effectRef>
-          <a:fontRef idx="minor">
-            <a:schemeClr val="lt1"/>
-          </a:fontRef>
-        </p:style>
-        <p:txBody>
-          <a:bodyPr rtlCol="0" anchor="ctr"/>
-          <a:lstStyle/>
-          <a:p>
-            <a:pPr algn="ctr"/>
-            <a:endParaRPr lang="en-IN"/>
-          </a:p>
-        </p:txBody>
-      </p:sp>
-      <p:sp>
-        <p:nvSpPr>
-          <p:cNvPr id="12" name="Google Shape;100;p3"/>
-          <p:cNvSpPr txBox="1"/>
-          <p:nvPr/>
-        </p:nvSpPr>
-        <p:spPr>
-          <a:xfrm>
-            <a:off x="367832" y="1915454"/>
-            <a:ext cx="11764736" cy="4070356"/>
-          </a:xfrm>
-          <a:prstGeom prst="rect">
-            <a:avLst/>
-          </a:prstGeom>
-          <a:noFill/>
-          <a:ln>
-            <a:noFill/>
-          </a:ln>
-        </p:spPr>
-        <p:txBody>
-          <a:bodyPr spcFirstLastPara="1" wrap="square" lIns="91425" tIns="45700" rIns="91425" bIns="45700" anchor="t" anchorCtr="0">
-            <a:noAutofit/>
-          </a:bodyPr>
-          <a:lstStyle/>
-          <a:p>
-            <a:pPr marL="514350" marR="0" lvl="0" indent="-514350" algn="just" rtl="0">
-              <a:lnSpc>
-                <a:spcPct val="90000"/>
-              </a:lnSpc>
-              <a:spcBef>
-                <a:spcPts val="0"/>
-              </a:spcBef>
-              <a:spcAft>
-                <a:spcPts val="0"/>
-              </a:spcAft>
-              <a:buClr>
-                <a:schemeClr val="dk1"/>
-              </a:buClr>
-              <a:buSzPct val="100000"/>
-              <a:buFont typeface="Calibri"/>
-              <a:buAutoNum type="arabicPeriod"/>
-            </a:pPr>
-            <a:r>
-              <a:rPr lang="en-US" b="1" i="0" u="none" strike="noStrike" cap="none" dirty="0">
-                <a:solidFill>
-                  <a:schemeClr val="dk1"/>
-                </a:solidFill>
-                <a:latin typeface="Arial" panose="020B0604020202020204" pitchFamily="34" charset="0"/>
-                <a:ea typeface="Calibri"/>
-                <a:cs typeface="Arial" panose="020B0604020202020204" pitchFamily="34" charset="0"/>
-                <a:sym typeface="Calibri"/>
-              </a:rPr>
-              <a:t>Kindly keep the maximum slides limit up to six </a:t>
-            </a:r>
-            <a:r>
-              <a:rPr lang="en-US" b="1" i="0" u="none" strike="noStrike" cap="none" dirty="0">
-                <a:solidFill>
-                  <a:srgbClr val="C00000"/>
-                </a:solidFill>
-                <a:latin typeface="Arial" panose="020B0604020202020204" pitchFamily="34" charset="0"/>
-                <a:ea typeface="Calibri"/>
-                <a:cs typeface="Arial" panose="020B0604020202020204" pitchFamily="34" charset="0"/>
-                <a:sym typeface="Calibri"/>
-              </a:rPr>
-              <a:t>(6). </a:t>
-            </a:r>
-            <a:r>
-              <a:rPr lang="en-US" b="1" i="0" u="none" strike="noStrike" cap="none" dirty="0">
-                <a:solidFill>
-                  <a:schemeClr val="dk1"/>
-                </a:solidFill>
-                <a:latin typeface="Arial" panose="020B0604020202020204" pitchFamily="34" charset="0"/>
-                <a:ea typeface="Calibri"/>
-                <a:cs typeface="Arial" panose="020B0604020202020204" pitchFamily="34" charset="0"/>
-                <a:sym typeface="Calibri"/>
-              </a:rPr>
-              <a:t>( Including the </a:t>
-            </a:r>
-            <a:r>
-              <a:rPr lang="en-US" b="1" i="0" u="none" strike="noStrike" cap="none">
-                <a:solidFill>
-                  <a:schemeClr val="dk1"/>
-                </a:solidFill>
-                <a:latin typeface="Arial" panose="020B0604020202020204" pitchFamily="34" charset="0"/>
-                <a:ea typeface="Calibri"/>
-                <a:cs typeface="Arial" panose="020B0604020202020204" pitchFamily="34" charset="0"/>
-                <a:sym typeface="Calibri"/>
-              </a:rPr>
-              <a:t>title slide) </a:t>
-            </a:r>
-            <a:endParaRPr b="1" dirty="0">
-              <a:latin typeface="Arial" panose="020B0604020202020204" pitchFamily="34" charset="0"/>
-              <a:cs typeface="Arial" panose="020B0604020202020204" pitchFamily="34" charset="0"/>
-            </a:endParaRPr>
-          </a:p>
-          <a:p>
-            <a:pPr marL="514350" marR="0" lvl="0" indent="-514350" algn="just" rtl="0">
-              <a:lnSpc>
-                <a:spcPct val="90000"/>
-              </a:lnSpc>
-              <a:spcBef>
-                <a:spcPts val="1000"/>
-              </a:spcBef>
-              <a:spcAft>
-                <a:spcPts val="0"/>
-              </a:spcAft>
-              <a:buClr>
-                <a:schemeClr val="dk1"/>
-              </a:buClr>
-              <a:buSzPct val="100000"/>
-              <a:buFont typeface="Calibri"/>
-              <a:buAutoNum type="arabicPeriod"/>
-            </a:pPr>
-            <a:r>
-              <a:rPr lang="en-US" b="1" i="0" u="none" strike="noStrike" cap="none" dirty="0">
-                <a:solidFill>
-                  <a:schemeClr val="dk1"/>
-                </a:solidFill>
-                <a:latin typeface="Arial" panose="020B0604020202020204" pitchFamily="34" charset="0"/>
-                <a:ea typeface="Calibri"/>
-                <a:cs typeface="Arial" panose="020B0604020202020204" pitchFamily="34" charset="0"/>
-                <a:sym typeface="Calibri"/>
-              </a:rPr>
-              <a:t>Try to avoid paragraphs and post your idea in points /diagrams / Infographics /pictures </a:t>
-            </a:r>
-            <a:endParaRPr b="1" dirty="0">
-              <a:latin typeface="Arial" panose="020B0604020202020204" pitchFamily="34" charset="0"/>
-              <a:cs typeface="Arial" panose="020B0604020202020204" pitchFamily="34" charset="0"/>
-            </a:endParaRPr>
-          </a:p>
-          <a:p>
-            <a:pPr marL="514350" marR="0" lvl="0" indent="-514350" algn="just" rtl="0">
-              <a:lnSpc>
-                <a:spcPct val="90000"/>
-              </a:lnSpc>
-              <a:spcBef>
-                <a:spcPts val="1000"/>
-              </a:spcBef>
-              <a:spcAft>
-                <a:spcPts val="0"/>
-              </a:spcAft>
-              <a:buClr>
-                <a:schemeClr val="dk1"/>
-              </a:buClr>
-              <a:buSzPct val="100000"/>
-              <a:buFont typeface="Calibri"/>
-              <a:buAutoNum type="arabicPeriod"/>
-            </a:pPr>
-            <a:r>
-              <a:rPr lang="en-US" b="1" i="0" u="none" strike="noStrike" cap="none" dirty="0">
-                <a:solidFill>
-                  <a:schemeClr val="dk1"/>
-                </a:solidFill>
-                <a:latin typeface="Arial" panose="020B0604020202020204" pitchFamily="34" charset="0"/>
-                <a:ea typeface="Calibri"/>
-                <a:cs typeface="Arial" panose="020B0604020202020204" pitchFamily="34" charset="0"/>
-                <a:sym typeface="Calibri"/>
-              </a:rPr>
-              <a:t>Keep your explanation precise and easy to understand</a:t>
-            </a:r>
-            <a:endParaRPr b="1" dirty="0">
-              <a:latin typeface="Arial" panose="020B0604020202020204" pitchFamily="34" charset="0"/>
-              <a:cs typeface="Arial" panose="020B0604020202020204" pitchFamily="34" charset="0"/>
-            </a:endParaRPr>
-          </a:p>
-          <a:p>
-            <a:pPr marL="514350" marR="0" lvl="0" indent="-514350" algn="just" rtl="0">
-              <a:lnSpc>
-                <a:spcPct val="90000"/>
-              </a:lnSpc>
-              <a:spcBef>
-                <a:spcPts val="1000"/>
-              </a:spcBef>
-              <a:spcAft>
-                <a:spcPts val="0"/>
-              </a:spcAft>
-              <a:buClr>
-                <a:schemeClr val="dk1"/>
-              </a:buClr>
-              <a:buSzPct val="100000"/>
-              <a:buFont typeface="Calibri"/>
-              <a:buAutoNum type="arabicPeriod"/>
-            </a:pPr>
-            <a:r>
-              <a:rPr lang="en-US" b="1" i="0" u="none" strike="noStrike" cap="none" dirty="0">
-                <a:solidFill>
-                  <a:schemeClr val="dk1"/>
-                </a:solidFill>
-                <a:latin typeface="Arial" panose="020B0604020202020204" pitchFamily="34" charset="0"/>
-                <a:ea typeface="Calibri"/>
-                <a:cs typeface="Arial" panose="020B0604020202020204" pitchFamily="34" charset="0"/>
-                <a:sym typeface="Calibri"/>
-              </a:rPr>
-              <a:t>Idea should be unique and novel. </a:t>
-            </a:r>
-            <a:endParaRPr b="1" dirty="0">
-              <a:latin typeface="Arial" panose="020B0604020202020204" pitchFamily="34" charset="0"/>
-              <a:cs typeface="Arial" panose="020B0604020202020204" pitchFamily="34" charset="0"/>
-            </a:endParaRPr>
-          </a:p>
-          <a:p>
-            <a:pPr marL="514350" marR="0" lvl="0" indent="-514350" algn="just" rtl="0">
-              <a:lnSpc>
-                <a:spcPct val="90000"/>
-              </a:lnSpc>
-              <a:spcBef>
-                <a:spcPts val="1000"/>
-              </a:spcBef>
-              <a:spcAft>
-                <a:spcPts val="0"/>
-              </a:spcAft>
-              <a:buClr>
-                <a:schemeClr val="dk1"/>
-              </a:buClr>
-              <a:buSzPct val="100000"/>
-              <a:buFont typeface="Calibri"/>
-              <a:buAutoNum type="arabicPeriod"/>
-            </a:pPr>
-            <a:r>
-              <a:rPr lang="en-US" b="1" i="0" u="none" strike="noStrike" cap="none" dirty="0">
-                <a:solidFill>
-                  <a:schemeClr val="dk1"/>
-                </a:solidFill>
-                <a:latin typeface="Arial" panose="020B0604020202020204" pitchFamily="34" charset="0"/>
-                <a:ea typeface="Calibri"/>
-                <a:cs typeface="Arial" panose="020B0604020202020204" pitchFamily="34" charset="0"/>
-                <a:sym typeface="Calibri"/>
-              </a:rPr>
-              <a:t>You can only use provided </a:t>
-            </a:r>
-            <a:r>
-              <a:rPr lang="en-US" b="1" dirty="0">
-                <a:solidFill>
-                  <a:schemeClr val="dk1"/>
-                </a:solidFill>
-                <a:latin typeface="Arial" panose="020B0604020202020204" pitchFamily="34" charset="0"/>
-                <a:ea typeface="Calibri"/>
-                <a:cs typeface="Arial" panose="020B0604020202020204" pitchFamily="34" charset="0"/>
-                <a:sym typeface="Calibri"/>
-              </a:rPr>
-              <a:t>template</a:t>
-            </a:r>
-            <a:r>
-              <a:rPr lang="en-US" b="1" i="0" u="none" strike="noStrike" cap="none" dirty="0">
-                <a:solidFill>
-                  <a:schemeClr val="dk1"/>
-                </a:solidFill>
-                <a:latin typeface="Arial" panose="020B0604020202020204" pitchFamily="34" charset="0"/>
-                <a:ea typeface="Calibri"/>
-                <a:cs typeface="Arial" panose="020B0604020202020204" pitchFamily="34" charset="0"/>
-                <a:sym typeface="Calibri"/>
-              </a:rPr>
-              <a:t> for making the </a:t>
-            </a:r>
-            <a:r>
-              <a:rPr lang="en-US" b="1" dirty="0">
-                <a:solidFill>
-                  <a:schemeClr val="dk1"/>
-                </a:solidFill>
-                <a:latin typeface="Arial" panose="020B0604020202020204" pitchFamily="34" charset="0"/>
-                <a:ea typeface="Calibri"/>
-                <a:cs typeface="Arial" panose="020B0604020202020204" pitchFamily="34" charset="0"/>
-                <a:sym typeface="Calibri"/>
-              </a:rPr>
-              <a:t>PPT</a:t>
-            </a:r>
-            <a:r>
-              <a:rPr lang="en-US" b="1" i="0" u="none" strike="noStrike" cap="none" dirty="0">
-                <a:solidFill>
-                  <a:schemeClr val="dk1"/>
-                </a:solidFill>
-                <a:latin typeface="Arial" panose="020B0604020202020204" pitchFamily="34" charset="0"/>
-                <a:ea typeface="Calibri"/>
-                <a:cs typeface="Arial" panose="020B0604020202020204" pitchFamily="34" charset="0"/>
-                <a:sym typeface="Calibri"/>
-              </a:rPr>
-              <a:t> without changing the idea details pointers (mentioned in previous slides).</a:t>
-            </a:r>
-            <a:endParaRPr b="1" i="0" u="none" strike="noStrike" cap="none" dirty="0">
-              <a:solidFill>
-                <a:schemeClr val="dk1"/>
-              </a:solidFill>
-              <a:latin typeface="Arial" panose="020B0604020202020204" pitchFamily="34" charset="0"/>
-              <a:ea typeface="Calibri"/>
-              <a:cs typeface="Arial" panose="020B0604020202020204" pitchFamily="34" charset="0"/>
-              <a:sym typeface="Calibri"/>
-            </a:endParaRPr>
-          </a:p>
-          <a:p>
-            <a:pPr marL="514350" marR="0" lvl="0" indent="-514350" algn="just" rtl="0">
-              <a:lnSpc>
-                <a:spcPct val="90000"/>
-              </a:lnSpc>
-              <a:spcBef>
-                <a:spcPts val="1000"/>
-              </a:spcBef>
-              <a:spcAft>
-                <a:spcPts val="0"/>
-              </a:spcAft>
-              <a:buClr>
-                <a:schemeClr val="dk1"/>
-              </a:buClr>
-              <a:buSzPct val="100000"/>
-              <a:buFont typeface="Calibri"/>
-              <a:buAutoNum type="arabicPeriod"/>
-            </a:pPr>
-            <a:r>
-              <a:rPr lang="en-US" b="1" i="0" u="none" strike="noStrike" cap="none" dirty="0">
-                <a:solidFill>
-                  <a:schemeClr val="dk1"/>
-                </a:solidFill>
-                <a:latin typeface="Arial" panose="020B0604020202020204" pitchFamily="34" charset="0"/>
-                <a:ea typeface="Calibri"/>
-                <a:cs typeface="Arial" panose="020B0604020202020204" pitchFamily="34" charset="0"/>
-                <a:sym typeface="Calibri"/>
-              </a:rPr>
-              <a:t>You need to save the file in PDF and upload the same on portal. No PPT, Word Doc or any other format will be supported.</a:t>
-            </a:r>
-            <a:endParaRPr b="1" dirty="0">
-              <a:latin typeface="Arial" panose="020B0604020202020204" pitchFamily="34" charset="0"/>
-              <a:cs typeface="Arial" panose="020B0604020202020204" pitchFamily="34" charset="0"/>
-            </a:endParaRPr>
-          </a:p>
-          <a:p>
-            <a:pPr marL="514350" marR="0" lvl="0" indent="-349885" algn="just" rtl="0">
-              <a:lnSpc>
-                <a:spcPct val="90000"/>
-              </a:lnSpc>
-              <a:spcBef>
-                <a:spcPts val="1000"/>
-              </a:spcBef>
-              <a:spcAft>
-                <a:spcPts val="0"/>
-              </a:spcAft>
-              <a:buClr>
-                <a:schemeClr val="dk1"/>
-              </a:buClr>
-              <a:buSzPct val="100000"/>
-              <a:buFont typeface="Calibri"/>
-              <a:buNone/>
-            </a:pPr>
-            <a:endParaRPr b="1" i="0" u="none" strike="noStrike" cap="none" dirty="0">
-              <a:solidFill>
-                <a:schemeClr val="dk1"/>
-              </a:solidFill>
-              <a:latin typeface="Arial" panose="020B0604020202020204" pitchFamily="34" charset="0"/>
-              <a:ea typeface="Calibri"/>
-              <a:cs typeface="Arial" panose="020B0604020202020204" pitchFamily="34" charset="0"/>
-              <a:sym typeface="Calibri"/>
-            </a:endParaRPr>
-          </a:p>
-          <a:p>
-            <a:pPr marL="0" marR="0" lvl="0" indent="0" algn="just" rtl="0">
-              <a:lnSpc>
-                <a:spcPct val="90000"/>
-              </a:lnSpc>
-              <a:spcBef>
-                <a:spcPts val="1000"/>
-              </a:spcBef>
-              <a:spcAft>
-                <a:spcPts val="0"/>
-              </a:spcAft>
-              <a:buClr>
-                <a:schemeClr val="dk1"/>
-              </a:buClr>
-              <a:buSzPct val="100000"/>
-              <a:buFont typeface="Arial"/>
-              <a:buNone/>
-            </a:pPr>
-            <a:r>
-              <a:rPr lang="en-US" b="1" i="0" u="none" strike="noStrike" cap="none" dirty="0">
-                <a:solidFill>
-                  <a:srgbClr val="C00000"/>
-                </a:solidFill>
-                <a:latin typeface="Arial" panose="020B0604020202020204" pitchFamily="34" charset="0"/>
-                <a:ea typeface="Calibri"/>
-                <a:cs typeface="Arial" panose="020B0604020202020204" pitchFamily="34" charset="0"/>
-                <a:sym typeface="Calibri"/>
-              </a:rPr>
-              <a:t>Note - You can delete this slide (Important Pointers) when you upload the details of your idea on SIH portal.</a:t>
-            </a:r>
-            <a:endParaRPr b="1" dirty="0">
-              <a:solidFill>
-                <a:srgbClr val="C00000"/>
-              </a:solidFill>
-              <a:latin typeface="Arial" panose="020B0604020202020204" pitchFamily="34" charset="0"/>
-              <a:cs typeface="Arial" panose="020B0604020202020204" pitchFamily="34" charset="0"/>
-            </a:endParaRPr>
-          </a:p>
-          <a:p>
-            <a:pPr marL="914400" marR="0" lvl="1" indent="-316230" algn="just" rtl="0">
-              <a:lnSpc>
-                <a:spcPct val="90000"/>
-              </a:lnSpc>
-              <a:spcBef>
-                <a:spcPts val="500"/>
-              </a:spcBef>
-              <a:spcAft>
-                <a:spcPts val="0"/>
-              </a:spcAft>
-              <a:buClr>
-                <a:schemeClr val="dk1"/>
-              </a:buClr>
-              <a:buSzPct val="100000"/>
-              <a:buFont typeface="Calibri"/>
-              <a:buNone/>
-            </a:pPr>
-            <a:endParaRPr sz="2000" b="1" i="0" u="none" strike="noStrike" cap="none" dirty="0">
-              <a:solidFill>
-                <a:schemeClr val="dk1"/>
-              </a:solidFill>
-              <a:latin typeface="Arial" panose="020B0604020202020204" pitchFamily="34" charset="0"/>
-              <a:ea typeface="Calibri"/>
-              <a:cs typeface="Arial" panose="020B0604020202020204" pitchFamily="34" charset="0"/>
-              <a:sym typeface="Calibri"/>
-            </a:endParaRPr>
-          </a:p>
-        </p:txBody>
-      </p:sp>
-      <p:sp>
-        <p:nvSpPr>
-          <p:cNvPr id="4" name="TextBox 3"/>
-          <p:cNvSpPr txBox="1"/>
-          <p:nvPr/>
-        </p:nvSpPr>
-        <p:spPr>
-          <a:xfrm>
-            <a:off x="1393371" y="107066"/>
-            <a:ext cx="8410540" cy="646331"/>
-          </a:xfrm>
-          <a:prstGeom prst="rect">
-            <a:avLst/>
-          </a:prstGeom>
-          <a:noFill/>
-        </p:spPr>
-        <p:txBody>
-          <a:bodyPr wrap="square" rtlCol="0">
-            <a:spAutoFit/>
-          </a:bodyPr>
-          <a:lstStyle/>
-          <a:p>
-            <a:pPr algn="ctr"/>
-            <a:r>
-              <a:rPr lang="en-US" sz="3600" b="1" dirty="0">
-                <a:latin typeface="Times New Roman" panose="02020603050405020304" pitchFamily="18" charset="0"/>
-                <a:cs typeface="Times New Roman" panose="02020603050405020304" pitchFamily="18" charset="0"/>
-              </a:rPr>
-              <a:t>IMPORTANT INSTRUCTIONS</a:t>
-            </a:r>
-            <a:endParaRPr lang="en-IN" sz="3600" b="1" dirty="0">
-              <a:latin typeface="Times New Roman" panose="02020603050405020304" pitchFamily="18" charset="0"/>
-              <a:cs typeface="Times New Roman" panose="02020603050405020304" pitchFamily="18" charset="0"/>
-            </a:endParaRPr>
-          </a:p>
-        </p:txBody>
-      </p:sp>
-      <p:sp>
-        <p:nvSpPr>
-          <p:cNvPr id="5" name="TextBox 4"/>
-          <p:cNvSpPr txBox="1"/>
-          <p:nvPr/>
-        </p:nvSpPr>
-        <p:spPr>
-          <a:xfrm>
-            <a:off x="602343" y="1181900"/>
-            <a:ext cx="9557657" cy="341632"/>
-          </a:xfrm>
-          <a:prstGeom prst="rect">
-            <a:avLst/>
-          </a:prstGeom>
-          <a:noFill/>
-        </p:spPr>
-        <p:txBody>
-          <a:bodyPr wrap="square" rtlCol="0">
-            <a:spAutoFit/>
-          </a:bodyPr>
-          <a:lstStyle/>
-          <a:p>
-            <a:pPr algn="just">
-              <a:lnSpc>
-                <a:spcPct val="90000"/>
-              </a:lnSpc>
-              <a:spcBef>
-                <a:spcPts val="1000"/>
-              </a:spcBef>
-              <a:spcAft>
-                <a:spcPts val="0"/>
-              </a:spcAft>
-              <a:buClr>
-                <a:schemeClr val="dk1"/>
-              </a:buClr>
-              <a:buSzPct val="100000"/>
-            </a:pPr>
-            <a:r>
-              <a:rPr lang="en-US" b="1" dirty="0">
-                <a:solidFill>
-                  <a:schemeClr val="dk1"/>
-                </a:solidFill>
-                <a:latin typeface="Arial" panose="020B0604020202020204" pitchFamily="34" charset="0"/>
-                <a:ea typeface="Calibri"/>
-                <a:cs typeface="Arial" panose="020B0604020202020204" pitchFamily="34" charset="0"/>
-              </a:rPr>
-              <a:t>Please ensure below pointers are met while submitting the Idea PPT:</a:t>
-            </a:r>
-            <a:endParaRPr lang="en-IN" b="1" dirty="0">
-              <a:solidFill>
-                <a:schemeClr val="dk1"/>
-              </a:solidFill>
-              <a:latin typeface="Arial" panose="020B0604020202020204" pitchFamily="34" charset="0"/>
-              <a:ea typeface="Calibri"/>
-              <a:cs typeface="Arial" panose="020B0604020202020204" pitchFamily="34" charset="0"/>
-            </a:endParaRPr>
-          </a:p>
-        </p:txBody>
-      </p:sp>
-      <p:pic>
-        <p:nvPicPr>
-          <p:cNvPr id="13" name="Picture 12"/>
-          <p:cNvPicPr>
-            <a:picLocks noChangeAspect="1"/>
-          </p:cNvPicPr>
-          <p:nvPr/>
-        </p:nvPicPr>
-        <p:blipFill>
-          <a:blip r:embed="rId3">
-            <a:extLst>
-              <a:ext uri="{28A0092B-C50C-407E-A947-70E740481C1C}">
-                <a14:useLocalDpi xmlns:a14="http://schemas.microsoft.com/office/drawing/2010/main" val="0"/>
-              </a:ext>
-            </a:extLst>
-          </a:blip>
-          <a:stretch>
-            <a:fillRect/>
-          </a:stretch>
-        </p:blipFill>
-        <p:spPr>
-          <a:xfrm>
-            <a:off x="9780086" y="1500"/>
-            <a:ext cx="2249850" cy="1062337"/>
-          </a:xfrm>
-          <a:prstGeom prst="rect">
-            <a:avLst/>
-          </a:prstGeom>
-        </p:spPr>
-      </p:pic>
-    </p:spTree>
-    <p:extLst>
-      <p:ext uri="{BB962C8B-B14F-4D97-AF65-F5344CB8AC3E}">
-        <p14:creationId xmlns:p14="http://schemas.microsoft.com/office/powerpoint/2010/main" val="1588084416"/>
       </p:ext>
     </p:extLst>
   </p:cSld>

</xml_diff>